<commit_message>
fix(r1.0): align SSA, force-replace, take-ownership, server dry-run wording; podman push; deck polish; reconciliation plan
</commit_message>
<xml_diff>
--- a/presentation/helm-101/Helm-101-r1.0.pptx
+++ b/presentation/helm-101/Helm-101-r1.0.pptx
@@ -2825,7 +2825,7 @@
           <a:p>
             <a:r>
               <a:rPr lang="en-US" dirty="0"/>
-              <a:t>What it shows: the Helm 4 apply model. A release created by Helm 3 stays on client-side apply until --server-side is set explicitly on an upgrade. With server-side apply, Helm stops with a conflict when another field manager owns a field it wants to set to a different value. The tutorial's step 8 patches spec.replicas with kubectl patch --field-manager=hfd-demo, so a plain helm upgrade stops, and the --force-conflicts upgrade resolves it. Step 9 shows the refusal to adopt an unowned ConfigMap, then adoption with --take-ownership. The design is in HIP-0023. What to show: examples/12-release-lifecycle, ./demo.sh steps 8 and 9. Fallback: chapter 12, section Server-side apply, ownership and conflicts. The Helm 3 force spelling remains in Helm 4 with a deprecation warning and is covered in the flag map at the end.</a:t>
+              <a:t>What it shows: the Helm 4 apply model. A release created by Helm 3 stays on client-side apply until --server-side is set explicitly on an upgrade. With server-side apply, Helm stops with a conflict when another field manager owns a field it wants to set to a different value. The tutorial's step 8 patches spec.replicas with kubectl patch --field-manager=hfd-demo, so a plain helm upgrade stops, and the --force-conflicts upgrade resolves it. Step 9 shows the refusal to adopt an unowned ConfigMap, then adoption, which on 4.3.0 needs --take-ownership --force-conflicts because the existing fields belong to another manager. Step 10 shows --force-replace rejected under server-side apply and working with --server-side=false. The design is in HIP-0023. What to show: examples/12-release-lifecycle, ./demo.sh steps 8 and 9. Fallback: chapter 12, section Server-side apply, ownership and conflicts. The Helm 3 force spelling remains in Helm 4 with a deprecation warning and is covered in the flag map at the end.</a:t>
             </a:r>
             <a:endParaRPr lang="en-US" dirty="0"/>
           </a:p>
@@ -2913,7 +2913,7 @@
           <a:p>
             <a:r>
               <a:rPr lang="en-US" dirty="0"/>
-              <a:t>What it shows: four levels of checking before anything changes in the cluster. helm lint renders every template and checks structure and the schema. helm template renders locally and, piped through kubeconform -strict, validates each object against the Kubernetes schemas; custom resources without a schema in the default catalog are skipped and reported in the summary. --dry-run=client renders and prints notes with no cluster connection. --dry-run=server connects, so lookup returns live objects and .Capabilities.APIVersions reflects the real cluster. In Helm 4, --dry-run takes none, client or server. What to show: ./demo.sh offline in examples/05-values and examples/10-crds-operators; the second expects the postgres render to fail without the operator and shows the guard message. Fallback: chapter 10, the operator guard section, and chapter 13 in the 201 for the full debugging ladder. Remember that lint does not resolve import-values.</a:t>
+              <a:t>What it shows: four levels of checking before anything changes in the cluster. helm lint renders every template and checks structure and the schema. helm template renders locally and, piped through kubeconform -strict, validates each object against the Kubernetes schemas; custom resources without a schema in the default catalog are skipped and reported in the summary. --dry-run=client renders and prints notes with no cluster connection. --dry-run=server connects, so kinds resolve against the API server, lookup returns live objects and .Capabilities.APIVersions reflects the real cluster. On Helm 4.3.0 it does not schema-validate fields: a string containerPort, an unknown field or a Pod Security violation all pass, so use kubeconform, or kubectl apply --server-side --dry-run=server on helm template output, for that. In Helm 4, --dry-run takes none, client or server. What to show: ./demo.sh offline in examples/05-values and examples/10-crds-operators; the second expects the postgres render to fail without the operator and shows the guard message. Fallback: chapter 10, the operator guard section, and chapter 13 in the 201 for the full debugging ladder. Remember that lint does not resolve import-values.</a:t>
             </a:r>
             <a:endParaRPr lang="en-US" dirty="0"/>
           </a:p>
@@ -17068,7 +17068,7 @@
                 <a:ea typeface="Red Hat Text" pitchFamily="34" charset="-122"/>
                 <a:cs typeface="Red Hat Text" pitchFamily="34" charset="-120"/>
               </a:rPr>
-              <a:t>: lets an upgrade adopt resources that lack Helm's ownership annotations.</a:t>
+              <a:t>: lets an upgrade adopt resources that lack Helm's ownership annotations; add --force-conflicts when another manager owns differing fields.</a:t>
             </a:r>
             <a:endParaRPr lang="en-US" sz="1700" dirty="0"/>
           </a:p>
@@ -17112,7 +17112,7 @@
                 <a:ea typeface="Red Hat Text" pitchFamily="34" charset="-122"/>
                 <a:cs typeface="Red Hat Text" pitchFamily="34" charset="-120"/>
               </a:rPr>
-              <a:t>: deletes and recreates objects, which changes an immutable field at the cost of brief downtime.</a:t>
+              <a:t>: replaces objects client-side; Helm 4.3.0 rejects it with server-side apply, so add --server-side=false.</a:t>
             </a:r>
             <a:endParaRPr lang="en-US" sz="1700" dirty="0"/>
           </a:p>
@@ -18484,7 +18484,7 @@
                           <a:ea typeface="Red Hat Text" pitchFamily="34" charset="-122"/>
                           <a:cs typeface="Red Hat Text" pitchFamily="34" charset="-120"/>
                         </a:rPr>
-                        <a:t>upgrade and rollback; both spellings warn</a:t>
+                        <a:t>client-side only: needs --server-side=false; both spellings warn</a:t>
                       </a:r>
                       <a:endParaRPr lang="en-US" sz="1300" dirty="0">
                         <a:latin typeface="Red Hat Text" charset="0"/>

</xml_diff>

<commit_message>
docs(§27): verify OpenShift Local appendix live on CRC 2.64.0 / OCP 4.22.14
</commit_message>
<xml_diff>
--- a/presentation/helm-101/Helm-101-r1.0.pptx
+++ b/presentation/helm-101/Helm-101-r1.0.pptx
@@ -4043,9 +4043,9 @@
                 <a:solidFill>
                   <a:srgbClr val="EE0000"/>
                 </a:solidFill>
-                <a:latin typeface="Overpass" pitchFamily="34" charset="0"/>
-                <a:ea typeface="Overpass" pitchFamily="34" charset="-122"/>
-                <a:cs typeface="Overpass" pitchFamily="34" charset="-120"/>
+                <a:latin typeface="Red Hat Display" pitchFamily="34" charset="0"/>
+                <a:ea typeface="Red Hat Display" pitchFamily="34" charset="-122"/>
+                <a:cs typeface="Red Hat Display" pitchFamily="34" charset="-120"/>
               </a:rPr>
               <a:t>HELM FOR DEVELOPERS · 101</a:t>
             </a:r>
@@ -4082,9 +4082,9 @@
                 <a:solidFill>
                   <a:srgbClr val="151515"/>
                 </a:solidFill>
-                <a:latin typeface="Overpass" pitchFamily="34" charset="0"/>
-                <a:ea typeface="Overpass" pitchFamily="34" charset="-122"/>
-                <a:cs typeface="Overpass" pitchFamily="34" charset="-120"/>
+                <a:latin typeface="Red Hat Display" pitchFamily="34" charset="0"/>
+                <a:ea typeface="Red Hat Display" pitchFamily="34" charset="-122"/>
+                <a:cs typeface="Red Hat Display" pitchFamily="34" charset="-120"/>
               </a:rPr>
               <a:t>Helm for</a:t>
             </a:r>
@@ -4099,9 +4099,9 @@
                 <a:solidFill>
                   <a:srgbClr val="151515"/>
                 </a:solidFill>
-                <a:latin typeface="Overpass" pitchFamily="34" charset="0"/>
-                <a:ea typeface="Overpass" pitchFamily="34" charset="-122"/>
-                <a:cs typeface="Overpass" pitchFamily="34" charset="-120"/>
+                <a:latin typeface="Red Hat Display" pitchFamily="34" charset="0"/>
+                <a:ea typeface="Red Hat Display" pitchFamily="34" charset="-122"/>
+                <a:cs typeface="Red Hat Display" pitchFamily="34" charset="-120"/>
               </a:rPr>
               <a:t>Developers 101</a:t>
             </a:r>
@@ -4296,9 +4296,9 @@
                 <a:solidFill>
                   <a:srgbClr val="FFFFFF"/>
                 </a:solidFill>
-                <a:latin typeface="Overpass" pitchFamily="34" charset="0"/>
-                <a:ea typeface="Overpass" pitchFamily="34" charset="-122"/>
-                <a:cs typeface="Overpass" pitchFamily="34" charset="-120"/>
+                <a:latin typeface="Red Hat Display" pitchFamily="34" charset="0"/>
+                <a:ea typeface="Red Hat Display" pitchFamily="34" charset="-122"/>
+                <a:cs typeface="Red Hat Display" pitchFamily="34" charset="-120"/>
               </a:rPr>
               <a:t>03</a:t>
             </a:r>
@@ -4335,9 +4335,9 @@
                 <a:solidFill>
                   <a:srgbClr val="FFFFFF"/>
                 </a:solidFill>
-                <a:latin typeface="Overpass" pitchFamily="34" charset="0"/>
-                <a:ea typeface="Overpass" pitchFamily="34" charset="-122"/>
-                <a:cs typeface="Overpass" pitchFamily="34" charset="-120"/>
+                <a:latin typeface="Red Hat Display" pitchFamily="34" charset="0"/>
+                <a:ea typeface="Red Hat Display" pitchFamily="34" charset="-122"/>
+                <a:cs typeface="Red Hat Display" pitchFamily="34" charset="-120"/>
               </a:rPr>
               <a:t>First chart</a:t>
             </a:r>
@@ -4525,9 +4525,9 @@
                 <a:solidFill>
                   <a:srgbClr val="EE0000"/>
                 </a:solidFill>
-                <a:latin typeface="Overpass" pitchFamily="34" charset="0"/>
-                <a:ea typeface="Overpass" pitchFamily="34" charset="-122"/>
-                <a:cs typeface="Overpass" pitchFamily="34" charset="-120"/>
+                <a:latin typeface="Red Hat Display" pitchFamily="34" charset="0"/>
+                <a:ea typeface="Red Hat Display" pitchFamily="34" charset="-122"/>
+                <a:cs typeface="Red Hat Display" pitchFamily="34" charset="-120"/>
               </a:rPr>
               <a:t>FIRST CHART · LAYOUT</a:t>
             </a:r>
@@ -4564,9 +4564,9 @@
                 <a:solidFill>
                   <a:srgbClr val="151515"/>
                 </a:solidFill>
-                <a:latin typeface="Overpass" pitchFamily="34" charset="0"/>
-                <a:ea typeface="Overpass" pitchFamily="34" charset="-122"/>
-                <a:cs typeface="Overpass" pitchFamily="34" charset="-120"/>
+                <a:latin typeface="Red Hat Display" pitchFamily="34" charset="0"/>
+                <a:ea typeface="Red Hat Display" pitchFamily="34" charset="-122"/>
+                <a:cs typeface="Red Hat Display" pitchFamily="34" charset="-120"/>
               </a:rPr>
               <a:t>Chart anatomy</a:t>
             </a:r>
@@ -5161,9 +5161,9 @@
                 <a:solidFill>
                   <a:srgbClr val="EE0000"/>
                 </a:solidFill>
-                <a:latin typeface="Overpass" pitchFamily="34" charset="0"/>
-                <a:ea typeface="Overpass" pitchFamily="34" charset="-122"/>
-                <a:cs typeface="Overpass" pitchFamily="34" charset="-120"/>
+                <a:latin typeface="Red Hat Display" pitchFamily="34" charset="0"/>
+                <a:ea typeface="Red Hat Display" pitchFamily="34" charset="-122"/>
+                <a:cs typeface="Red Hat Display" pitchFamily="34" charset="-120"/>
               </a:rPr>
               <a:t>FIRST CHART · METADATA</a:t>
             </a:r>
@@ -5200,9 +5200,9 @@
                 <a:solidFill>
                   <a:srgbClr val="151515"/>
                 </a:solidFill>
-                <a:latin typeface="Overpass" pitchFamily="34" charset="0"/>
-                <a:ea typeface="Overpass" pitchFamily="34" charset="-122"/>
-                <a:cs typeface="Overpass" pitchFamily="34" charset="-120"/>
+                <a:latin typeface="Red Hat Display" pitchFamily="34" charset="0"/>
+                <a:ea typeface="Red Hat Display" pitchFamily="34" charset="-122"/>
+                <a:cs typeface="Red Hat Display" pitchFamily="34" charset="-120"/>
               </a:rPr>
               <a:t>Chart metadata fields</a:t>
             </a:r>
@@ -5743,9 +5743,9 @@
                 <a:solidFill>
                   <a:srgbClr val="EE0000"/>
                 </a:solidFill>
-                <a:latin typeface="Overpass" pitchFamily="34" charset="0"/>
-                <a:ea typeface="Overpass" pitchFamily="34" charset="-122"/>
-                <a:cs typeface="Overpass" pitchFamily="34" charset="-120"/>
+                <a:latin typeface="Red Hat Display" pitchFamily="34" charset="0"/>
+                <a:ea typeface="Red Hat Display" pitchFamily="34" charset="-122"/>
+                <a:cs typeface="Red Hat Display" pitchFamily="34" charset="-120"/>
               </a:rPr>
               <a:t>FIRST CHART · LIFECYCLE</a:t>
             </a:r>
@@ -5782,9 +5782,9 @@
                 <a:solidFill>
                   <a:srgbClr val="151515"/>
                 </a:solidFill>
-                <a:latin typeface="Overpass" pitchFamily="34" charset="0"/>
-                <a:ea typeface="Overpass" pitchFamily="34" charset="-122"/>
-                <a:cs typeface="Overpass" pitchFamily="34" charset="-120"/>
+                <a:latin typeface="Red Hat Display" pitchFamily="34" charset="0"/>
+                <a:ea typeface="Red Hat Display" pitchFamily="34" charset="-122"/>
+                <a:cs typeface="Red Hat Display" pitchFamily="34" charset="-120"/>
               </a:rPr>
               <a:t>Install, upgrade, rollback</a:t>
             </a:r>
@@ -5971,9 +5971,9 @@
                 <a:solidFill>
                   <a:srgbClr val="EE0000"/>
                 </a:solidFill>
-                <a:latin typeface="Overpass" pitchFamily="34" charset="0"/>
-                <a:ea typeface="Overpass" pitchFamily="34" charset="-122"/>
-                <a:cs typeface="Overpass" pitchFamily="34" charset="-120"/>
+                <a:latin typeface="Red Hat Display" pitchFamily="34" charset="0"/>
+                <a:ea typeface="Red Hat Display" pitchFamily="34" charset="-122"/>
+                <a:cs typeface="Red Hat Display" pitchFamily="34" charset="-120"/>
               </a:rPr>
               <a:t>FIRST CHART · STORAGE</a:t>
             </a:r>
@@ -6010,9 +6010,9 @@
                 <a:solidFill>
                   <a:srgbClr val="151515"/>
                 </a:solidFill>
-                <a:latin typeface="Overpass" pitchFamily="34" charset="0"/>
-                <a:ea typeface="Overpass" pitchFamily="34" charset="-122"/>
-                <a:cs typeface="Overpass" pitchFamily="34" charset="-120"/>
+                <a:latin typeface="Red Hat Display" pitchFamily="34" charset="0"/>
+                <a:ea typeface="Red Hat Display" pitchFamily="34" charset="-122"/>
+                <a:cs typeface="Red Hat Display" pitchFamily="34" charset="-120"/>
               </a:rPr>
               <a:t>Release history and storage</a:t>
             </a:r>
@@ -6395,9 +6395,9 @@
                 <a:solidFill>
                   <a:srgbClr val="FFFFFF"/>
                 </a:solidFill>
-                <a:latin typeface="Overpass" pitchFamily="34" charset="0"/>
-                <a:ea typeface="Overpass" pitchFamily="34" charset="-122"/>
-                <a:cs typeface="Overpass" pitchFamily="34" charset="-120"/>
+                <a:latin typeface="Red Hat Display" pitchFamily="34" charset="0"/>
+                <a:ea typeface="Red Hat Display" pitchFamily="34" charset="-122"/>
+                <a:cs typeface="Red Hat Display" pitchFamily="34" charset="-120"/>
               </a:rPr>
               <a:t>04</a:t>
             </a:r>
@@ -6434,9 +6434,9 @@
                 <a:solidFill>
                   <a:srgbClr val="FFFFFF"/>
                 </a:solidFill>
-                <a:latin typeface="Overpass" pitchFamily="34" charset="0"/>
-                <a:ea typeface="Overpass" pitchFamily="34" charset="-122"/>
-                <a:cs typeface="Overpass" pitchFamily="34" charset="-120"/>
+                <a:latin typeface="Red Hat Display" pitchFamily="34" charset="0"/>
+                <a:ea typeface="Red Hat Display" pitchFamily="34" charset="-122"/>
+                <a:cs typeface="Red Hat Display" pitchFamily="34" charset="-120"/>
               </a:rPr>
               <a:t>Values</a:t>
             </a:r>
@@ -6624,9 +6624,9 @@
                 <a:solidFill>
                   <a:srgbClr val="EE0000"/>
                 </a:solidFill>
-                <a:latin typeface="Overpass" pitchFamily="34" charset="0"/>
-                <a:ea typeface="Overpass" pitchFamily="34" charset="-122"/>
-                <a:cs typeface="Overpass" pitchFamily="34" charset="-120"/>
+                <a:latin typeface="Red Hat Display" pitchFamily="34" charset="0"/>
+                <a:ea typeface="Red Hat Display" pitchFamily="34" charset="-122"/>
+                <a:cs typeface="Red Hat Display" pitchFamily="34" charset="-120"/>
               </a:rPr>
               <a:t>VALUES · MERGE ORDER</a:t>
             </a:r>
@@ -6663,9 +6663,9 @@
                 <a:solidFill>
                   <a:srgbClr val="151515"/>
                 </a:solidFill>
-                <a:latin typeface="Overpass" pitchFamily="34" charset="0"/>
-                <a:ea typeface="Overpass" pitchFamily="34" charset="-122"/>
-                <a:cs typeface="Overpass" pitchFamily="34" charset="-120"/>
+                <a:latin typeface="Red Hat Display" pitchFamily="34" charset="0"/>
+                <a:ea typeface="Red Hat Display" pitchFamily="34" charset="-122"/>
+                <a:cs typeface="Red Hat Display" pitchFamily="34" charset="-120"/>
               </a:rPr>
               <a:t>Values precedence</a:t>
             </a:r>
@@ -6852,9 +6852,9 @@
                 <a:solidFill>
                   <a:srgbClr val="EE0000"/>
                 </a:solidFill>
-                <a:latin typeface="Overpass" pitchFamily="34" charset="0"/>
-                <a:ea typeface="Overpass" pitchFamily="34" charset="-122"/>
-                <a:cs typeface="Overpass" pitchFamily="34" charset="-120"/>
+                <a:latin typeface="Red Hat Display" pitchFamily="34" charset="0"/>
+                <a:ea typeface="Red Hat Display" pitchFamily="34" charset="-122"/>
+                <a:cs typeface="Red Hat Display" pitchFamily="34" charset="-120"/>
               </a:rPr>
               <a:t>VALUES · COMMAND LINE</a:t>
             </a:r>
@@ -6891,9 +6891,9 @@
                 <a:solidFill>
                   <a:srgbClr val="151515"/>
                 </a:solidFill>
-                <a:latin typeface="Overpass" pitchFamily="34" charset="0"/>
-                <a:ea typeface="Overpass" pitchFamily="34" charset="-122"/>
-                <a:cs typeface="Overpass" pitchFamily="34" charset="-120"/>
+                <a:latin typeface="Red Hat Display" pitchFamily="34" charset="0"/>
+                <a:ea typeface="Red Hat Display" pitchFamily="34" charset="-122"/>
+                <a:cs typeface="Red Hat Display" pitchFamily="34" charset="-120"/>
               </a:rPr>
               <a:t>Override flags</a:t>
             </a:r>
@@ -7326,9 +7326,9 @@
                 <a:solidFill>
                   <a:srgbClr val="EE0000"/>
                 </a:solidFill>
-                <a:latin typeface="Overpass" pitchFamily="34" charset="0"/>
-                <a:ea typeface="Overpass" pitchFamily="34" charset="-122"/>
-                <a:cs typeface="Overpass" pitchFamily="34" charset="-120"/>
+                <a:latin typeface="Red Hat Display" pitchFamily="34" charset="0"/>
+                <a:ea typeface="Red Hat Display" pitchFamily="34" charset="-122"/>
+                <a:cs typeface="Red Hat Display" pitchFamily="34" charset="-120"/>
               </a:rPr>
               <a:t>VALUES · VALIDATION</a:t>
             </a:r>
@@ -7365,9 +7365,9 @@
                 <a:solidFill>
                   <a:srgbClr val="151515"/>
                 </a:solidFill>
-                <a:latin typeface="Overpass" pitchFamily="34" charset="0"/>
-                <a:ea typeface="Overpass" pitchFamily="34" charset="-122"/>
-                <a:cs typeface="Overpass" pitchFamily="34" charset="-120"/>
+                <a:latin typeface="Red Hat Display" pitchFamily="34" charset="0"/>
+                <a:ea typeface="Red Hat Display" pitchFamily="34" charset="-122"/>
+                <a:cs typeface="Red Hat Display" pitchFamily="34" charset="-120"/>
               </a:rPr>
               <a:t>Values schema</a:t>
             </a:r>
@@ -8146,9 +8146,9 @@
                 <a:solidFill>
                   <a:srgbClr val="FFFFFF"/>
                 </a:solidFill>
-                <a:latin typeface="Overpass" pitchFamily="34" charset="0"/>
-                <a:ea typeface="Overpass" pitchFamily="34" charset="-122"/>
-                <a:cs typeface="Overpass" pitchFamily="34" charset="-120"/>
+                <a:latin typeface="Red Hat Display" pitchFamily="34" charset="0"/>
+                <a:ea typeface="Red Hat Display" pitchFamily="34" charset="-122"/>
+                <a:cs typeface="Red Hat Display" pitchFamily="34" charset="-120"/>
               </a:rPr>
               <a:t>05</a:t>
             </a:r>
@@ -8185,9 +8185,9 @@
                 <a:solidFill>
                   <a:srgbClr val="FFFFFF"/>
                 </a:solidFill>
-                <a:latin typeface="Overpass" pitchFamily="34" charset="0"/>
-                <a:ea typeface="Overpass" pitchFamily="34" charset="-122"/>
-                <a:cs typeface="Overpass" pitchFamily="34" charset="-120"/>
+                <a:latin typeface="Red Hat Display" pitchFamily="34" charset="0"/>
+                <a:ea typeface="Red Hat Display" pitchFamily="34" charset="-122"/>
+                <a:cs typeface="Red Hat Display" pitchFamily="34" charset="-120"/>
               </a:rPr>
               <a:t>Templates</a:t>
             </a:r>
@@ -8375,9 +8375,9 @@
                 <a:solidFill>
                   <a:srgbClr val="EE0000"/>
                 </a:solidFill>
-                <a:latin typeface="Overpass" pitchFamily="34" charset="0"/>
-                <a:ea typeface="Overpass" pitchFamily="34" charset="-122"/>
-                <a:cs typeface="Overpass" pitchFamily="34" charset="-120"/>
+                <a:latin typeface="Red Hat Display" pitchFamily="34" charset="0"/>
+                <a:ea typeface="Red Hat Display" pitchFamily="34" charset="-122"/>
+                <a:cs typeface="Red Hat Display" pitchFamily="34" charset="-120"/>
               </a:rPr>
               <a:t>101 · SCOPE</a:t>
             </a:r>
@@ -8414,9 +8414,9 @@
                 <a:solidFill>
                   <a:srgbClr val="151515"/>
                 </a:solidFill>
-                <a:latin typeface="Overpass" pitchFamily="34" charset="0"/>
-                <a:ea typeface="Overpass" pitchFamily="34" charset="-122"/>
-                <a:cs typeface="Overpass" pitchFamily="34" charset="-120"/>
+                <a:latin typeface="Red Hat Display" pitchFamily="34" charset="0"/>
+                <a:ea typeface="Red Hat Display" pitchFamily="34" charset="-122"/>
+                <a:cs typeface="Red Hat Display" pitchFamily="34" charset="-120"/>
               </a:rPr>
               <a:t>Session agenda</a:t>
             </a:r>
@@ -8777,9 +8777,9 @@
                 <a:solidFill>
                   <a:srgbClr val="EE0000"/>
                 </a:solidFill>
-                <a:latin typeface="Overpass" pitchFamily="34" charset="0"/>
-                <a:ea typeface="Overpass" pitchFamily="34" charset="-122"/>
-                <a:cs typeface="Overpass" pitchFamily="34" charset="-120"/>
+                <a:latin typeface="Red Hat Display" pitchFamily="34" charset="0"/>
+                <a:ea typeface="Red Hat Display" pitchFamily="34" charset="-122"/>
+                <a:cs typeface="Red Hat Display" pitchFamily="34" charset="-120"/>
               </a:rPr>
               <a:t>TEMPLATES · SYNTAX</a:t>
             </a:r>
@@ -8816,9 +8816,9 @@
                 <a:solidFill>
                   <a:srgbClr val="151515"/>
                 </a:solidFill>
-                <a:latin typeface="Overpass" pitchFamily="34" charset="0"/>
-                <a:ea typeface="Overpass" pitchFamily="34" charset="-122"/>
-                <a:cs typeface="Overpass" pitchFamily="34" charset="-120"/>
+                <a:latin typeface="Red Hat Display" pitchFamily="34" charset="0"/>
+                <a:ea typeface="Red Hat Display" pitchFamily="34" charset="-122"/>
+                <a:cs typeface="Red Hat Display" pitchFamily="34" charset="-120"/>
               </a:rPr>
               <a:t>Go templates and Sprig</a:t>
             </a:r>
@@ -9449,9 +9449,9 @@
                 <a:solidFill>
                   <a:srgbClr val="EE0000"/>
                 </a:solidFill>
-                <a:latin typeface="Overpass" pitchFamily="34" charset="0"/>
-                <a:ea typeface="Overpass" pitchFamily="34" charset="-122"/>
-                <a:cs typeface="Overpass" pitchFamily="34" charset="-120"/>
+                <a:latin typeface="Red Hat Display" pitchFamily="34" charset="0"/>
+                <a:ea typeface="Red Hat Display" pitchFamily="34" charset="-122"/>
+                <a:cs typeface="Red Hat Display" pitchFamily="34" charset="-120"/>
               </a:rPr>
               <a:t>TEMPLATES · CONTROL</a:t>
             </a:r>
@@ -9488,9 +9488,9 @@
                 <a:solidFill>
                   <a:srgbClr val="151515"/>
                 </a:solidFill>
-                <a:latin typeface="Overpass" pitchFamily="34" charset="0"/>
-                <a:ea typeface="Overpass" pitchFamily="34" charset="-122"/>
-                <a:cs typeface="Overpass" pitchFamily="34" charset="-120"/>
+                <a:latin typeface="Red Hat Display" pitchFamily="34" charset="0"/>
+                <a:ea typeface="Red Hat Display" pitchFamily="34" charset="-122"/>
+                <a:cs typeface="Red Hat Display" pitchFamily="34" charset="-120"/>
               </a:rPr>
               <a:t>Flow control and scope</a:t>
             </a:r>
@@ -10013,9 +10013,9 @@
                 <a:solidFill>
                   <a:srgbClr val="EE0000"/>
                 </a:solidFill>
-                <a:latin typeface="Overpass" pitchFamily="34" charset="0"/>
-                <a:ea typeface="Overpass" pitchFamily="34" charset="-122"/>
-                <a:cs typeface="Overpass" pitchFamily="34" charset="-120"/>
+                <a:latin typeface="Red Hat Display" pitchFamily="34" charset="0"/>
+                <a:ea typeface="Red Hat Display" pitchFamily="34" charset="-122"/>
+                <a:cs typeface="Red Hat Display" pitchFamily="34" charset="-120"/>
               </a:rPr>
               <a:t>TEMPLATES · REUSE</a:t>
             </a:r>
@@ -10052,9 +10052,9 @@
                 <a:solidFill>
                   <a:srgbClr val="151515"/>
                 </a:solidFill>
-                <a:latin typeface="Overpass" pitchFamily="34" charset="0"/>
-                <a:ea typeface="Overpass" pitchFamily="34" charset="-122"/>
-                <a:cs typeface="Overpass" pitchFamily="34" charset="-120"/>
+                <a:latin typeface="Red Hat Display" pitchFamily="34" charset="0"/>
+                <a:ea typeface="Red Hat Display" pitchFamily="34" charset="-122"/>
+                <a:cs typeface="Red Hat Display" pitchFamily="34" charset="-120"/>
               </a:rPr>
               <a:t>Named templates</a:t>
             </a:r>
@@ -10739,9 +10739,9 @@
                 <a:solidFill>
                   <a:srgbClr val="EE0000"/>
                 </a:solidFill>
-                <a:latin typeface="Overpass" pitchFamily="34" charset="0"/>
-                <a:ea typeface="Overpass" pitchFamily="34" charset="-122"/>
-                <a:cs typeface="Overpass" pitchFamily="34" charset="-120"/>
+                <a:latin typeface="Red Hat Display" pitchFamily="34" charset="0"/>
+                <a:ea typeface="Red Hat Display" pitchFamily="34" charset="-122"/>
+                <a:cs typeface="Red Hat Display" pitchFamily="34" charset="-120"/>
               </a:rPr>
               <a:t>TEMPLATES · FUNCTIONS</a:t>
             </a:r>
@@ -10778,9 +10778,9 @@
                 <a:solidFill>
                   <a:srgbClr val="151515"/>
                 </a:solidFill>
-                <a:latin typeface="Overpass" pitchFamily="34" charset="0"/>
-                <a:ea typeface="Overpass" pitchFamily="34" charset="-122"/>
-                <a:cs typeface="Overpass" pitchFamily="34" charset="-120"/>
+                <a:latin typeface="Red Hat Display" pitchFamily="34" charset="0"/>
+                <a:ea typeface="Red Hat Display" pitchFamily="34" charset="-122"/>
+                <a:cs typeface="Red Hat Display" pitchFamily="34" charset="-120"/>
               </a:rPr>
               <a:t>tpl, required, fail, lookup</a:t>
             </a:r>
@@ -11724,9 +11724,9 @@
                 <a:solidFill>
                   <a:srgbClr val="EE0000"/>
                 </a:solidFill>
-                <a:latin typeface="Overpass" pitchFamily="34" charset="0"/>
-                <a:ea typeface="Overpass" pitchFamily="34" charset="-122"/>
-                <a:cs typeface="Overpass" pitchFamily="34" charset="-120"/>
+                <a:latin typeface="Red Hat Display" pitchFamily="34" charset="0"/>
+                <a:ea typeface="Red Hat Display" pitchFamily="34" charset="-122"/>
+                <a:cs typeface="Red Hat Display" pitchFamily="34" charset="-120"/>
               </a:rPr>
               <a:t>TEMPLATES · POST-INSTALL</a:t>
             </a:r>
@@ -11763,9 +11763,9 @@
                 <a:solidFill>
                   <a:srgbClr val="151515"/>
                 </a:solidFill>
-                <a:latin typeface="Overpass" pitchFamily="34" charset="0"/>
-                <a:ea typeface="Overpass" pitchFamily="34" charset="-122"/>
-                <a:cs typeface="Overpass" pitchFamily="34" charset="-120"/>
+                <a:latin typeface="Red Hat Display" pitchFamily="34" charset="0"/>
+                <a:ea typeface="Red Hat Display" pitchFamily="34" charset="-122"/>
+                <a:cs typeface="Red Hat Display" pitchFamily="34" charset="-120"/>
               </a:rPr>
               <a:t>Post-install notes</a:t>
             </a:r>
@@ -12202,9 +12202,9 @@
                 <a:solidFill>
                   <a:srgbClr val="FFFFFF"/>
                 </a:solidFill>
-                <a:latin typeface="Overpass" pitchFamily="34" charset="0"/>
-                <a:ea typeface="Overpass" pitchFamily="34" charset="-122"/>
-                <a:cs typeface="Overpass" pitchFamily="34" charset="-120"/>
+                <a:latin typeface="Red Hat Display" pitchFamily="34" charset="0"/>
+                <a:ea typeface="Red Hat Display" pitchFamily="34" charset="-122"/>
+                <a:cs typeface="Red Hat Display" pitchFamily="34" charset="-120"/>
               </a:rPr>
               <a:t>06</a:t>
             </a:r>
@@ -12241,9 +12241,9 @@
                 <a:solidFill>
                   <a:srgbClr val="FFFFFF"/>
                 </a:solidFill>
-                <a:latin typeface="Overpass" pitchFamily="34" charset="0"/>
-                <a:ea typeface="Overpass" pitchFamily="34" charset="-122"/>
-                <a:cs typeface="Overpass" pitchFamily="34" charset="-120"/>
+                <a:latin typeface="Red Hat Display" pitchFamily="34" charset="0"/>
+                <a:ea typeface="Red Hat Display" pitchFamily="34" charset="-122"/>
+                <a:cs typeface="Red Hat Display" pitchFamily="34" charset="-120"/>
               </a:rPr>
               <a:t>Config, data, hooks</a:t>
             </a:r>
@@ -12431,9 +12431,9 @@
                 <a:solidFill>
                   <a:srgbClr val="EE0000"/>
                 </a:solidFill>
-                <a:latin typeface="Overpass" pitchFamily="34" charset="0"/>
-                <a:ea typeface="Overpass" pitchFamily="34" charset="-122"/>
-                <a:cs typeface="Overpass" pitchFamily="34" charset="-120"/>
+                <a:latin typeface="Red Hat Display" pitchFamily="34" charset="0"/>
+                <a:ea typeface="Red Hat Display" pitchFamily="34" charset="-122"/>
+                <a:cs typeface="Red Hat Display" pitchFamily="34" charset="-120"/>
               </a:rPr>
               <a:t>CONFIG · ROLLOUTS</a:t>
             </a:r>
@@ -12470,9 +12470,9 @@
                 <a:solidFill>
                   <a:srgbClr val="151515"/>
                 </a:solidFill>
-                <a:latin typeface="Overpass" pitchFamily="34" charset="0"/>
-                <a:ea typeface="Overpass" pitchFamily="34" charset="-122"/>
-                <a:cs typeface="Overpass" pitchFamily="34" charset="-120"/>
+                <a:latin typeface="Red Hat Display" pitchFamily="34" charset="0"/>
+                <a:ea typeface="Red Hat Display" pitchFamily="34" charset="-122"/>
+                <a:cs typeface="Red Hat Display" pitchFamily="34" charset="-120"/>
               </a:rPr>
               <a:t>Config rollouts with checksums</a:t>
             </a:r>
@@ -12995,9 +12995,9 @@
                 <a:solidFill>
                   <a:srgbClr val="EE0000"/>
                 </a:solidFill>
-                <a:latin typeface="Overpass" pitchFamily="34" charset="0"/>
-                <a:ea typeface="Overpass" pitchFamily="34" charset="-122"/>
-                <a:cs typeface="Overpass" pitchFamily="34" charset="-120"/>
+                <a:latin typeface="Red Hat Display" pitchFamily="34" charset="0"/>
+                <a:ea typeface="Red Hat Display" pitchFamily="34" charset="-122"/>
+                <a:cs typeface="Red Hat Display" pitchFamily="34" charset="-120"/>
               </a:rPr>
               <a:t>CONFIG · SECRETS</a:t>
             </a:r>
@@ -13034,9 +13034,9 @@
                 <a:solidFill>
                   <a:srgbClr val="151515"/>
                 </a:solidFill>
-                <a:latin typeface="Overpass" pitchFamily="34" charset="0"/>
-                <a:ea typeface="Overpass" pitchFamily="34" charset="-122"/>
-                <a:cs typeface="Overpass" pitchFamily="34" charset="-120"/>
+                <a:latin typeface="Red Hat Display" pitchFamily="34" charset="0"/>
+                <a:ea typeface="Red Hat Display" pitchFamily="34" charset="-122"/>
+                <a:cs typeface="Red Hat Display" pitchFamily="34" charset="-120"/>
               </a:rPr>
               <a:t>Secret management options</a:t>
             </a:r>
@@ -14177,9 +14177,9 @@
                 <a:solidFill>
                   <a:srgbClr val="EE0000"/>
                 </a:solidFill>
-                <a:latin typeface="Overpass" pitchFamily="34" charset="0"/>
-                <a:ea typeface="Overpass" pitchFamily="34" charset="-122"/>
-                <a:cs typeface="Overpass" pitchFamily="34" charset="-120"/>
+                <a:latin typeface="Red Hat Display" pitchFamily="34" charset="0"/>
+                <a:ea typeface="Red Hat Display" pitchFamily="34" charset="-122"/>
+                <a:cs typeface="Red Hat Display" pitchFamily="34" charset="-120"/>
               </a:rPr>
               <a:t>DATA · DEPENDENCIES</a:t>
             </a:r>
@@ -14216,9 +14216,9 @@
                 <a:solidFill>
                   <a:srgbClr val="151515"/>
                 </a:solidFill>
-                <a:latin typeface="Overpass" pitchFamily="34" charset="0"/>
-                <a:ea typeface="Overpass" pitchFamily="34" charset="-122"/>
-                <a:cs typeface="Overpass" pitchFamily="34" charset="-120"/>
+                <a:latin typeface="Red Hat Display" pitchFamily="34" charset="0"/>
+                <a:ea typeface="Red Hat Display" pitchFamily="34" charset="-122"/>
+                <a:cs typeface="Red Hat Display" pitchFamily="34" charset="-120"/>
               </a:rPr>
               <a:t>Subcharts and the Postgres operator</a:t>
             </a:r>
@@ -14405,9 +14405,9 @@
                 <a:solidFill>
                   <a:srgbClr val="EE0000"/>
                 </a:solidFill>
-                <a:latin typeface="Overpass" pitchFamily="34" charset="0"/>
-                <a:ea typeface="Overpass" pitchFamily="34" charset="-122"/>
-                <a:cs typeface="Overpass" pitchFamily="34" charset="-120"/>
+                <a:latin typeface="Red Hat Display" pitchFamily="34" charset="0"/>
+                <a:ea typeface="Red Hat Display" pitchFamily="34" charset="-122"/>
+                <a:cs typeface="Red Hat Display" pitchFamily="34" charset="-120"/>
               </a:rPr>
               <a:t>DATA · HOOKS</a:t>
             </a:r>
@@ -14444,9 +14444,9 @@
                 <a:solidFill>
                   <a:srgbClr val="151515"/>
                 </a:solidFill>
-                <a:latin typeface="Overpass" pitchFamily="34" charset="0"/>
-                <a:ea typeface="Overpass" pitchFamily="34" charset="-122"/>
-                <a:cs typeface="Overpass" pitchFamily="34" charset="-120"/>
+                <a:latin typeface="Red Hat Display" pitchFamily="34" charset="0"/>
+                <a:ea typeface="Red Hat Display" pitchFamily="34" charset="-122"/>
+                <a:cs typeface="Red Hat Display" pitchFamily="34" charset="-120"/>
               </a:rPr>
               <a:t>Migration hooks</a:t>
             </a:r>
@@ -14601,9 +14601,9 @@
                 <a:solidFill>
                   <a:srgbClr val="FFFFFF"/>
                 </a:solidFill>
-                <a:latin typeface="Overpass" pitchFamily="34" charset="0"/>
-                <a:ea typeface="Overpass" pitchFamily="34" charset="-122"/>
-                <a:cs typeface="Overpass" pitchFamily="34" charset="-120"/>
+                <a:latin typeface="Red Hat Display" pitchFamily="34" charset="0"/>
+                <a:ea typeface="Red Hat Display" pitchFamily="34" charset="-122"/>
+                <a:cs typeface="Red Hat Display" pitchFamily="34" charset="-120"/>
               </a:rPr>
               <a:t>01</a:t>
             </a:r>
@@ -14640,9 +14640,9 @@
                 <a:solidFill>
                   <a:srgbClr val="FFFFFF"/>
                 </a:solidFill>
-                <a:latin typeface="Overpass" pitchFamily="34" charset="0"/>
-                <a:ea typeface="Overpass" pitchFamily="34" charset="-122"/>
-                <a:cs typeface="Overpass" pitchFamily="34" charset="-120"/>
+                <a:latin typeface="Red Hat Display" pitchFamily="34" charset="0"/>
+                <a:ea typeface="Red Hat Display" pitchFamily="34" charset="-122"/>
+                <a:cs typeface="Red Hat Display" pitchFamily="34" charset="-120"/>
               </a:rPr>
               <a:t>Why Helm</a:t>
             </a:r>
@@ -14830,9 +14830,9 @@
                 <a:solidFill>
                   <a:srgbClr val="EE0000"/>
                 </a:solidFill>
-                <a:latin typeface="Overpass" pitchFamily="34" charset="0"/>
-                <a:ea typeface="Overpass" pitchFamily="34" charset="-122"/>
-                <a:cs typeface="Overpass" pitchFamily="34" charset="-120"/>
+                <a:latin typeface="Red Hat Display" pitchFamily="34" charset="0"/>
+                <a:ea typeface="Red Hat Display" pitchFamily="34" charset="-122"/>
+                <a:cs typeface="Red Hat Display" pitchFamily="34" charset="-120"/>
               </a:rPr>
               <a:t>DATA · HOOK CONTROLS</a:t>
             </a:r>
@@ -14869,9 +14869,9 @@
                 <a:solidFill>
                   <a:srgbClr val="151515"/>
                 </a:solidFill>
-                <a:latin typeface="Overpass" pitchFamily="34" charset="0"/>
-                <a:ea typeface="Overpass" pitchFamily="34" charset="-122"/>
-                <a:cs typeface="Overpass" pitchFamily="34" charset="-120"/>
+                <a:latin typeface="Red Hat Display" pitchFamily="34" charset="0"/>
+                <a:ea typeface="Red Hat Display" pitchFamily="34" charset="-122"/>
+                <a:cs typeface="Red Hat Display" pitchFamily="34" charset="-120"/>
               </a:rPr>
               <a:t>Hook weights and policies</a:t>
             </a:r>
@@ -15980,9 +15980,9 @@
                 <a:solidFill>
                   <a:srgbClr val="FFFFFF"/>
                 </a:solidFill>
-                <a:latin typeface="Overpass" pitchFamily="34" charset="0"/>
-                <a:ea typeface="Overpass" pitchFamily="34" charset="-122"/>
-                <a:cs typeface="Overpass" pitchFamily="34" charset="-120"/>
+                <a:latin typeface="Red Hat Display" pitchFamily="34" charset="0"/>
+                <a:ea typeface="Red Hat Display" pitchFamily="34" charset="-122"/>
+                <a:cs typeface="Red Hat Display" pitchFamily="34" charset="-120"/>
               </a:rPr>
               <a:t>07</a:t>
             </a:r>
@@ -16019,9 +16019,9 @@
                 <a:solidFill>
                   <a:srgbClr val="FFFFFF"/>
                 </a:solidFill>
-                <a:latin typeface="Overpass" pitchFamily="34" charset="0"/>
-                <a:ea typeface="Overpass" pitchFamily="34" charset="-122"/>
-                <a:cs typeface="Overpass" pitchFamily="34" charset="-120"/>
+                <a:latin typeface="Red Hat Display" pitchFamily="34" charset="0"/>
+                <a:ea typeface="Red Hat Display" pitchFamily="34" charset="-122"/>
+                <a:cs typeface="Red Hat Display" pitchFamily="34" charset="-120"/>
               </a:rPr>
               <a:t>Safe releases</a:t>
             </a:r>
@@ -16209,9 +16209,9 @@
                 <a:solidFill>
                   <a:srgbClr val="EE0000"/>
                 </a:solidFill>
-                <a:latin typeface="Overpass" pitchFamily="34" charset="0"/>
-                <a:ea typeface="Overpass" pitchFamily="34" charset="-122"/>
-                <a:cs typeface="Overpass" pitchFamily="34" charset="-120"/>
+                <a:latin typeface="Red Hat Display" pitchFamily="34" charset="0"/>
+                <a:ea typeface="Red Hat Display" pitchFamily="34" charset="-122"/>
+                <a:cs typeface="Red Hat Display" pitchFamily="34" charset="-120"/>
               </a:rPr>
               <a:t>SAFE RELEASES · FAILURE</a:t>
             </a:r>
@@ -16248,9 +16248,9 @@
                 <a:solidFill>
                   <a:srgbClr val="151515"/>
                 </a:solidFill>
-                <a:latin typeface="Overpass" pitchFamily="34" charset="0"/>
-                <a:ea typeface="Overpass" pitchFamily="34" charset="-122"/>
-                <a:cs typeface="Overpass" pitchFamily="34" charset="-120"/>
+                <a:latin typeface="Red Hat Display" pitchFamily="34" charset="0"/>
+                <a:ea typeface="Red Hat Display" pitchFamily="34" charset="-122"/>
+                <a:cs typeface="Red Hat Display" pitchFamily="34" charset="-120"/>
               </a:rPr>
               <a:t>Wait and rollback-on-failure</a:t>
             </a:r>
@@ -16827,9 +16827,9 @@
                 <a:solidFill>
                   <a:srgbClr val="EE0000"/>
                 </a:solidFill>
-                <a:latin typeface="Overpass" pitchFamily="34" charset="0"/>
-                <a:ea typeface="Overpass" pitchFamily="34" charset="-122"/>
-                <a:cs typeface="Overpass" pitchFamily="34" charset="-120"/>
+                <a:latin typeface="Red Hat Display" pitchFamily="34" charset="0"/>
+                <a:ea typeface="Red Hat Display" pitchFamily="34" charset="-122"/>
+                <a:cs typeface="Red Hat Display" pitchFamily="34" charset="-120"/>
               </a:rPr>
               <a:t>SAFE RELEASES · APPLY</a:t>
             </a:r>
@@ -16866,9 +16866,9 @@
                 <a:solidFill>
                   <a:srgbClr val="151515"/>
                 </a:solidFill>
-                <a:latin typeface="Overpass" pitchFamily="34" charset="0"/>
-                <a:ea typeface="Overpass" pitchFamily="34" charset="-122"/>
-                <a:cs typeface="Overpass" pitchFamily="34" charset="-120"/>
+                <a:latin typeface="Red Hat Display" pitchFamily="34" charset="0"/>
+                <a:ea typeface="Red Hat Display" pitchFamily="34" charset="-122"/>
+                <a:cs typeface="Red Hat Display" pitchFamily="34" charset="-120"/>
               </a:rPr>
               <a:t>Server-side apply</a:t>
             </a:r>
@@ -17235,9 +17235,9 @@
                 <a:solidFill>
                   <a:srgbClr val="EE0000"/>
                 </a:solidFill>
-                <a:latin typeface="Overpass" pitchFamily="34" charset="0"/>
-                <a:ea typeface="Overpass" pitchFamily="34" charset="-122"/>
-                <a:cs typeface="Overpass" pitchFamily="34" charset="-120"/>
+                <a:latin typeface="Red Hat Display" pitchFamily="34" charset="0"/>
+                <a:ea typeface="Red Hat Display" pitchFamily="34" charset="-122"/>
+                <a:cs typeface="Red Hat Display" pitchFamily="34" charset="-120"/>
               </a:rPr>
               <a:t>SAFE RELEASES · VERIFY</a:t>
             </a:r>
@@ -17274,9 +17274,9 @@
                 <a:solidFill>
                   <a:srgbClr val="151515"/>
                 </a:solidFill>
-                <a:latin typeface="Overpass" pitchFamily="34" charset="0"/>
-                <a:ea typeface="Overpass" pitchFamily="34" charset="-122"/>
-                <a:cs typeface="Overpass" pitchFamily="34" charset="-120"/>
+                <a:latin typeface="Red Hat Display" pitchFamily="34" charset="0"/>
+                <a:ea typeface="Red Hat Display" pitchFamily="34" charset="-122"/>
+                <a:cs typeface="Red Hat Display" pitchFamily="34" charset="-120"/>
               </a:rPr>
               <a:t>Lint, template, dry-run</a:t>
             </a:r>
@@ -17655,9 +17655,9 @@
                 <a:solidFill>
                   <a:srgbClr val="EE0000"/>
                 </a:solidFill>
-                <a:latin typeface="Overpass" pitchFamily="34" charset="0"/>
-                <a:ea typeface="Overpass" pitchFamily="34" charset="-122"/>
-                <a:cs typeface="Overpass" pitchFamily="34" charset="-120"/>
+                <a:latin typeface="Red Hat Display" pitchFamily="34" charset="0"/>
+                <a:ea typeface="Red Hat Display" pitchFamily="34" charset="-122"/>
+                <a:cs typeface="Red Hat Display" pitchFamily="34" charset="-120"/>
               </a:rPr>
               <a:t>NEXT STEPS</a:t>
             </a:r>
@@ -17694,9 +17694,9 @@
                 <a:solidFill>
                   <a:srgbClr val="151515"/>
                 </a:solidFill>
-                <a:latin typeface="Overpass" pitchFamily="34" charset="0"/>
-                <a:ea typeface="Overpass" pitchFamily="34" charset="-122"/>
-                <a:cs typeface="Overpass" pitchFamily="34" charset="-120"/>
+                <a:latin typeface="Red Hat Display" pitchFamily="34" charset="0"/>
+                <a:ea typeface="Red Hat Display" pitchFamily="34" charset="-122"/>
+                <a:cs typeface="Red Hat Display" pitchFamily="34" charset="-120"/>
               </a:rPr>
               <a:t>Next: Helm 201</a:t>
             </a:r>
@@ -18063,9 +18063,9 @@
                 <a:solidFill>
                   <a:srgbClr val="EE0000"/>
                 </a:solidFill>
-                <a:latin typeface="Overpass" pitchFamily="34" charset="0"/>
-                <a:ea typeface="Overpass" pitchFamily="34" charset="-122"/>
-                <a:cs typeface="Overpass" pitchFamily="34" charset="-120"/>
+                <a:latin typeface="Red Hat Display" pitchFamily="34" charset="0"/>
+                <a:ea typeface="Red Hat Display" pitchFamily="34" charset="-122"/>
+                <a:cs typeface="Red Hat Display" pitchFamily="34" charset="-120"/>
               </a:rPr>
               <a:t>APPENDIX · MIGRATION</a:t>
             </a:r>
@@ -18102,9 +18102,9 @@
                 <a:solidFill>
                   <a:srgbClr val="151515"/>
                 </a:solidFill>
-                <a:latin typeface="Overpass" pitchFamily="34" charset="0"/>
-                <a:ea typeface="Overpass" pitchFamily="34" charset="-122"/>
-                <a:cs typeface="Overpass" pitchFamily="34" charset="-120"/>
+                <a:latin typeface="Red Hat Display" pitchFamily="34" charset="0"/>
+                <a:ea typeface="Red Hat Display" pitchFamily="34" charset="-122"/>
+                <a:cs typeface="Red Hat Display" pitchFamily="34" charset="-120"/>
               </a:rPr>
               <a:t>Helm 3 to 4 flag map</a:t>
             </a:r>
@@ -19442,9 +19442,9 @@
                 <a:solidFill>
                   <a:srgbClr val="EE0000"/>
                 </a:solidFill>
-                <a:latin typeface="Overpass" pitchFamily="34" charset="0"/>
-                <a:ea typeface="Overpass" pitchFamily="34" charset="-122"/>
-                <a:cs typeface="Overpass" pitchFamily="34" charset="-120"/>
+                <a:latin typeface="Red Hat Display" pitchFamily="34" charset="0"/>
+                <a:ea typeface="Red Hat Display" pitchFamily="34" charset="-122"/>
+                <a:cs typeface="Red Hat Display" pitchFamily="34" charset="-120"/>
               </a:rPr>
               <a:t>WHY HELM · THE PROBLEM</a:t>
             </a:r>
@@ -19481,9 +19481,9 @@
                 <a:solidFill>
                   <a:srgbClr val="151515"/>
                 </a:solidFill>
-                <a:latin typeface="Overpass" pitchFamily="34" charset="0"/>
-                <a:ea typeface="Overpass" pitchFamily="34" charset="-122"/>
-                <a:cs typeface="Overpass" pitchFamily="34" charset="-120"/>
+                <a:latin typeface="Red Hat Display" pitchFamily="34" charset="0"/>
+                <a:ea typeface="Red Hat Display" pitchFamily="34" charset="-122"/>
+                <a:cs typeface="Red Hat Display" pitchFamily="34" charset="-120"/>
               </a:rPr>
               <a:t>YAML across environments</a:t>
             </a:r>
@@ -19670,9 +19670,9 @@
                 <a:solidFill>
                   <a:srgbClr val="EE0000"/>
                 </a:solidFill>
-                <a:latin typeface="Overpass" pitchFamily="34" charset="0"/>
-                <a:ea typeface="Overpass" pitchFamily="34" charset="-122"/>
-                <a:cs typeface="Overpass" pitchFamily="34" charset="-120"/>
+                <a:latin typeface="Red Hat Display" pitchFamily="34" charset="0"/>
+                <a:ea typeface="Red Hat Display" pitchFamily="34" charset="-122"/>
+                <a:cs typeface="Red Hat Display" pitchFamily="34" charset="-120"/>
               </a:rPr>
               <a:t>WHY HELM · THE TOOL</a:t>
             </a:r>
@@ -19709,9 +19709,9 @@
                 <a:solidFill>
                   <a:srgbClr val="151515"/>
                 </a:solidFill>
-                <a:latin typeface="Overpass" pitchFamily="34" charset="0"/>
-                <a:ea typeface="Overpass" pitchFamily="34" charset="-122"/>
-                <a:cs typeface="Overpass" pitchFamily="34" charset="-120"/>
+                <a:latin typeface="Red Hat Display" pitchFamily="34" charset="0"/>
+                <a:ea typeface="Red Hat Display" pitchFamily="34" charset="-122"/>
+                <a:cs typeface="Red Hat Display" pitchFamily="34" charset="-120"/>
               </a:rPr>
               <a:t>Package and release manager</a:t>
             </a:r>
@@ -20034,9 +20034,9 @@
                 <a:solidFill>
                   <a:srgbClr val="EE0000"/>
                 </a:solidFill>
-                <a:latin typeface="Overpass" pitchFamily="34" charset="0"/>
-                <a:ea typeface="Overpass" pitchFamily="34" charset="-122"/>
-                <a:cs typeface="Overpass" pitchFamily="34" charset="-120"/>
+                <a:latin typeface="Red Hat Display" pitchFamily="34" charset="0"/>
+                <a:ea typeface="Red Hat Display" pitchFamily="34" charset="-122"/>
+                <a:cs typeface="Red Hat Display" pitchFamily="34" charset="-120"/>
               </a:rPr>
               <a:t>WHY HELM · HELM 4</a:t>
             </a:r>
@@ -20073,9 +20073,9 @@
                 <a:solidFill>
                   <a:srgbClr val="151515"/>
                 </a:solidFill>
-                <a:latin typeface="Overpass" pitchFamily="34" charset="0"/>
-                <a:ea typeface="Overpass" pitchFamily="34" charset="-122"/>
-                <a:cs typeface="Overpass" pitchFamily="34" charset="-120"/>
+                <a:latin typeface="Red Hat Display" pitchFamily="34" charset="0"/>
+                <a:ea typeface="Red Hat Display" pitchFamily="34" charset="-122"/>
+                <a:cs typeface="Red Hat Display" pitchFamily="34" charset="-120"/>
               </a:rPr>
               <a:t>Helm 4 at a glance</a:t>
             </a:r>
@@ -21381,9 +21381,9 @@
                 <a:solidFill>
                   <a:srgbClr val="FFFFFF"/>
                 </a:solidFill>
-                <a:latin typeface="Overpass" pitchFamily="34" charset="0"/>
-                <a:ea typeface="Overpass" pitchFamily="34" charset="-122"/>
-                <a:cs typeface="Overpass" pitchFamily="34" charset="-120"/>
+                <a:latin typeface="Red Hat Display" pitchFamily="34" charset="0"/>
+                <a:ea typeface="Red Hat Display" pitchFamily="34" charset="-122"/>
+                <a:cs typeface="Red Hat Display" pitchFamily="34" charset="-120"/>
               </a:rPr>
               <a:t>02</a:t>
             </a:r>
@@ -21420,9 +21420,9 @@
                 <a:solidFill>
                   <a:srgbClr val="FFFFFF"/>
                 </a:solidFill>
-                <a:latin typeface="Overpass" pitchFamily="34" charset="0"/>
-                <a:ea typeface="Overpass" pitchFamily="34" charset="-122"/>
-                <a:cs typeface="Overpass" pitchFamily="34" charset="-120"/>
+                <a:latin typeface="Red Hat Display" pitchFamily="34" charset="0"/>
+                <a:ea typeface="Red Hat Display" pitchFamily="34" charset="-122"/>
+                <a:cs typeface="Red Hat Display" pitchFamily="34" charset="-120"/>
               </a:rPr>
               <a:t>Core concepts</a:t>
             </a:r>
@@ -21610,9 +21610,9 @@
                 <a:solidFill>
                   <a:srgbClr val="EE0000"/>
                 </a:solidFill>
-                <a:latin typeface="Overpass" pitchFamily="34" charset="0"/>
-                <a:ea typeface="Overpass" pitchFamily="34" charset="-122"/>
-                <a:cs typeface="Overpass" pitchFamily="34" charset="-120"/>
+                <a:latin typeface="Red Hat Display" pitchFamily="34" charset="0"/>
+                <a:ea typeface="Red Hat Display" pitchFamily="34" charset="-122"/>
+                <a:cs typeface="Red Hat Display" pitchFamily="34" charset="-120"/>
               </a:rPr>
               <a:t>CORE CONCEPTS · VOCABULARY</a:t>
             </a:r>
@@ -21649,9 +21649,9 @@
                 <a:solidFill>
                   <a:srgbClr val="151515"/>
                 </a:solidFill>
-                <a:latin typeface="Overpass" pitchFamily="34" charset="0"/>
-                <a:ea typeface="Overpass" pitchFamily="34" charset="-122"/>
-                <a:cs typeface="Overpass" pitchFamily="34" charset="-120"/>
+                <a:latin typeface="Red Hat Display" pitchFamily="34" charset="0"/>
+                <a:ea typeface="Red Hat Display" pitchFamily="34" charset="-122"/>
+                <a:cs typeface="Red Hat Display" pitchFamily="34" charset="-120"/>
               </a:rPr>
               <a:t>Chart, release, repository, values</a:t>
             </a:r>
@@ -21974,9 +21974,9 @@
                 <a:solidFill>
                   <a:srgbClr val="EE0000"/>
                 </a:solidFill>
-                <a:latin typeface="Overpass" pitchFamily="34" charset="0"/>
-                <a:ea typeface="Overpass" pitchFamily="34" charset="-122"/>
-                <a:cs typeface="Overpass" pitchFamily="34" charset="-120"/>
+                <a:latin typeface="Red Hat Display" pitchFamily="34" charset="0"/>
+                <a:ea typeface="Red Hat Display" pitchFamily="34" charset="-122"/>
+                <a:cs typeface="Red Hat Display" pitchFamily="34" charset="-120"/>
               </a:rPr>
               <a:t>CORE CONCEPTS · ARCHITECTURE</a:t>
             </a:r>
@@ -22013,9 +22013,9 @@
                 <a:solidFill>
                   <a:srgbClr val="151515"/>
                 </a:solidFill>
-                <a:latin typeface="Overpass" pitchFamily="34" charset="0"/>
-                <a:ea typeface="Overpass" pitchFamily="34" charset="-122"/>
-                <a:cs typeface="Overpass" pitchFamily="34" charset="-120"/>
+                <a:latin typeface="Red Hat Display" pitchFamily="34" charset="0"/>
+                <a:ea typeface="Red Hat Display" pitchFamily="34" charset="-122"/>
+                <a:cs typeface="Red Hat Display" pitchFamily="34" charset="-120"/>
               </a:rPr>
               <a:t>Client-only architecture</a:t>
             </a:r>

</xml_diff>